<commit_message>
feat: Mettre à jour la présentation HESTIM Planner et améliorer la gestion des données dans l'application mobile
</commit_message>
<xml_diff>
--- a/docs/presentation/HESTIM-Planner-presentation.pptx
+++ b/docs/presentation/HESTIM-Planner-presentation.pptx
@@ -112,28 +112,28 @@
   <p:extLst>
     <p:ext uri="{521415D9-36F7-43E2-AB2F-B90AF26B5E84}">
       <p14:sectionLst xmlns:p14="http://schemas.microsoft.com/office/powerpoint/2010/main">
-        <p14:section name="Ouverture" id="{624febf0-d58a-a9e0-3b3c-9aea93368142}">
+        <p14:section name="Ouverture" id="{47fe19dc-f3a8-d0f6-b946-955a5c7bb45b}">
           <p14:sldIdLst>
             <p14:sldId id="256"/>
           </p14:sldIdLst>
         </p14:section>
-        <p14:section name="Le constat" id="{a2e0d926-dae4-fcc5-0fbd-ceffbbbff702}">
+        <p14:section name="Le constat" id="{3bb71db2-c99f-e2c2-903a-8bf9eabf45ca}">
           <p14:sldIdLst>
             <p14:sldId id="257"/>
           </p14:sldIdLst>
         </p14:section>
-        <p14:section name="L'offre" id="{26f4b2ab-c680-8e95-adeb-71b368758ec0}">
+        <p14:section name="L'offre" id="{83c99044-5bea-511d-e787-0f5a6739c6ee}">
           <p14:sldIdLst>
             <p14:sldId id="258"/>
             <p14:sldId id="259"/>
           </p14:sldIdLst>
         </p14:section>
-        <p14:section name="Les bénéfices" id="{2e6541ab-00b4-d844-aad9-402a0836a7fe}">
+        <p14:section name="Les bénéfices" id="{1ad43cfa-db0f-d536-2c2f-15ed6b367c3e}">
           <p14:sldIdLst>
             <p14:sldId id="260"/>
           </p14:sldIdLst>
         </p14:section>
-        <p14:section name="La suite" id="{75a9f957-2975-3bd8-2e16-b6ced48a3871}">
+        <p14:section name="La suite" id="{679fd210-9a0c-69b1-bccd-15ac7a68f1d3}">
           <p14:sldIdLst>
             <p14:sldId id="261"/>
           </p14:sldIdLst>
@@ -3064,7 +3064,7 @@
                 <a:ea typeface="Barlow Condensed" pitchFamily="34" charset="-122"/>
                 <a:cs typeface="Barlow Condensed" pitchFamily="34" charset="-120"/>
               </a:rPr>
-              <a:t>Sites de jeux externes</a:t>
+              <a:t>Sites de jeux</a:t>
             </a:r>
             <a:endParaRPr lang="en-US" sz="1900" dirty="0"/>
           </a:p>
@@ -3103,7 +3103,7 @@
                 <a:ea typeface="Barlow" pitchFamily="34" charset="-122"/>
                 <a:cs typeface="Barlow" pitchFamily="34" charset="-120"/>
               </a:rPr>
-              <a:t>Quiz et jeux en anglais et dans d'autres matières</a:t>
+              <a:t>Quiz et jeux externes, en anglais et dans d'autres matières</a:t>
             </a:r>
             <a:endParaRPr lang="en-US" sz="1300" dirty="0"/>
           </a:p>
@@ -5420,8 +5420,8 @@
         </p:nvSpPr>
         <p:spPr>
           <a:xfrm>
-            <a:off x="548640" y="1325880"/>
-            <a:ext cx="1417320" cy="1051560"/>
+            <a:off x="548640" y="1188720"/>
+            <a:ext cx="3474720" cy="822960"/>
           </a:xfrm>
           <a:prstGeom prst="rect">
             <a:avLst/>
@@ -5459,17 +5459,17 @@
         </p:nvSpPr>
         <p:spPr>
           <a:xfrm>
-            <a:off x="2057400" y="1325880"/>
-            <a:ext cx="2057400" cy="1051560"/>
-          </a:xfrm>
-          <a:prstGeom prst="rect">
-            <a:avLst/>
-          </a:prstGeom>
-          <a:noFill/>
-          <a:ln/>
-        </p:spPr>
-        <p:txBody>
-          <a:bodyPr wrap="square" lIns="0" tIns="0" rIns="0" bIns="0" rtlCol="0" anchor="ctr"/>
+            <a:off x="548640" y="2011680"/>
+            <a:ext cx="3474720" cy="548640"/>
+          </a:xfrm>
+          <a:prstGeom prst="rect">
+            <a:avLst/>
+          </a:prstGeom>
+          <a:noFill/>
+          <a:ln/>
+        </p:spPr>
+        <p:txBody>
+          <a:bodyPr wrap="square" lIns="0" tIns="0" rIns="0" bIns="0" rtlCol="0" anchor="t"/>
           <a:lstStyle/>
           <a:p>
             <a:pPr indent="0" marL="0">
@@ -5498,8 +5498,8 @@
         </p:nvSpPr>
         <p:spPr>
           <a:xfrm>
-            <a:off x="4297680" y="1325880"/>
-            <a:ext cx="1417320" cy="1051560"/>
+            <a:off x="4325112" y="1188720"/>
+            <a:ext cx="3474720" cy="822960"/>
           </a:xfrm>
           <a:prstGeom prst="rect">
             <a:avLst/>
@@ -5537,17 +5537,17 @@
         </p:nvSpPr>
         <p:spPr>
           <a:xfrm>
-            <a:off x="5806440" y="1325880"/>
-            <a:ext cx="2057400" cy="1051560"/>
-          </a:xfrm>
-          <a:prstGeom prst="rect">
-            <a:avLst/>
-          </a:prstGeom>
-          <a:noFill/>
-          <a:ln/>
-        </p:spPr>
-        <p:txBody>
-          <a:bodyPr wrap="square" lIns="0" tIns="0" rIns="0" bIns="0" rtlCol="0" anchor="ctr"/>
+            <a:off x="4325112" y="2011680"/>
+            <a:ext cx="3474720" cy="548640"/>
+          </a:xfrm>
+          <a:prstGeom prst="rect">
+            <a:avLst/>
+          </a:prstGeom>
+          <a:noFill/>
+          <a:ln/>
+        </p:spPr>
+        <p:txBody>
+          <a:bodyPr wrap="square" lIns="0" tIns="0" rIns="0" bIns="0" rtlCol="0" anchor="t"/>
           <a:lstStyle/>
           <a:p>
             <a:pPr indent="0" marL="0">
@@ -5576,8 +5576,8 @@
         </p:nvSpPr>
         <p:spPr>
           <a:xfrm>
-            <a:off x="8046720" y="1325880"/>
-            <a:ext cx="1417320" cy="1051560"/>
+            <a:off x="8101584" y="1188720"/>
+            <a:ext cx="3474720" cy="822960"/>
           </a:xfrm>
           <a:prstGeom prst="rect">
             <a:avLst/>
@@ -5615,17 +5615,17 @@
         </p:nvSpPr>
         <p:spPr>
           <a:xfrm>
-            <a:off x="9555480" y="1325880"/>
-            <a:ext cx="2057400" cy="1051560"/>
-          </a:xfrm>
-          <a:prstGeom prst="rect">
-            <a:avLst/>
-          </a:prstGeom>
-          <a:noFill/>
-          <a:ln/>
-        </p:spPr>
-        <p:txBody>
-          <a:bodyPr wrap="square" lIns="0" tIns="0" rIns="0" bIns="0" rtlCol="0" anchor="ctr"/>
+            <a:off x="8101584" y="2011680"/>
+            <a:ext cx="3474720" cy="548640"/>
+          </a:xfrm>
+          <a:prstGeom prst="rect">
+            <a:avLst/>
+          </a:prstGeom>
+          <a:noFill/>
+          <a:ln/>
+        </p:spPr>
+        <p:txBody>
+          <a:bodyPr wrap="square" lIns="0" tIns="0" rIns="0" bIns="0" rtlCol="0" anchor="t"/>
           <a:lstStyle/>
           <a:p>
             <a:pPr indent="0" marL="0">
@@ -5654,8 +5654,8 @@
         </p:nvSpPr>
         <p:spPr>
           <a:xfrm>
-            <a:off x="548640" y="2743200"/>
-            <a:ext cx="2606040" cy="3246120"/>
+            <a:off x="548640" y="2834640"/>
+            <a:ext cx="2606040" cy="3154680"/>
           </a:xfrm>
           <a:prstGeom prst="roundRect">
             <a:avLst>
@@ -5681,7 +5681,7 @@
         </p:nvSpPr>
         <p:spPr>
           <a:xfrm>
-            <a:off x="804672" y="3017520"/>
+            <a:off x="804672" y="3108960"/>
             <a:ext cx="603504" cy="603504"/>
           </a:xfrm>
           <a:prstGeom prst="ellipse">
@@ -5714,7 +5714,7 @@
         </p:blipFill>
         <p:spPr>
           <a:xfrm>
-            <a:off x="949513" y="3162361"/>
+            <a:off x="949513" y="3253801"/>
             <a:ext cx="313822" cy="313822"/>
           </a:xfrm>
           <a:prstGeom prst="rect">
@@ -5730,7 +5730,7 @@
         </p:nvSpPr>
         <p:spPr>
           <a:xfrm>
-            <a:off x="804672" y="3767328"/>
+            <a:off x="804672" y="3858768"/>
             <a:ext cx="2148840" cy="411480"/>
           </a:xfrm>
           <a:prstGeom prst="rect">
@@ -5769,7 +5769,7 @@
         </p:nvSpPr>
         <p:spPr>
           <a:xfrm>
-            <a:off x="804672" y="4251960"/>
+            <a:off x="804672" y="4343400"/>
             <a:ext cx="2148840" cy="1554480"/>
           </a:xfrm>
           <a:prstGeom prst="rect">
@@ -5808,8 +5808,8 @@
         </p:nvSpPr>
         <p:spPr>
           <a:xfrm>
-            <a:off x="3367735" y="2743200"/>
-            <a:ext cx="2606040" cy="3246120"/>
+            <a:off x="3367735" y="2834640"/>
+            <a:ext cx="2606040" cy="3154680"/>
           </a:xfrm>
           <a:prstGeom prst="roundRect">
             <a:avLst>
@@ -5835,7 +5835,7 @@
         </p:nvSpPr>
         <p:spPr>
           <a:xfrm>
-            <a:off x="3623767" y="3017520"/>
+            <a:off x="3623767" y="3108960"/>
             <a:ext cx="603504" cy="603504"/>
           </a:xfrm>
           <a:prstGeom prst="ellipse">
@@ -5868,7 +5868,7 @@
         </p:blipFill>
         <p:spPr>
           <a:xfrm>
-            <a:off x="3768608" y="3162361"/>
+            <a:off x="3768608" y="3253801"/>
             <a:ext cx="313822" cy="313822"/>
           </a:xfrm>
           <a:prstGeom prst="rect">
@@ -5884,7 +5884,7 @@
         </p:nvSpPr>
         <p:spPr>
           <a:xfrm>
-            <a:off x="3623767" y="3767328"/>
+            <a:off x="3623767" y="3858768"/>
             <a:ext cx="2148840" cy="411480"/>
           </a:xfrm>
           <a:prstGeom prst="rect">
@@ -5923,7 +5923,7 @@
         </p:nvSpPr>
         <p:spPr>
           <a:xfrm>
-            <a:off x="3623767" y="4251960"/>
+            <a:off x="3623767" y="4343400"/>
             <a:ext cx="2148840" cy="1554480"/>
           </a:xfrm>
           <a:prstGeom prst="rect">
@@ -5962,8 +5962,8 @@
         </p:nvSpPr>
         <p:spPr>
           <a:xfrm>
-            <a:off x="6186830" y="2743200"/>
-            <a:ext cx="2606040" cy="3246120"/>
+            <a:off x="6186830" y="2834640"/>
+            <a:ext cx="2606040" cy="3154680"/>
           </a:xfrm>
           <a:prstGeom prst="roundRect">
             <a:avLst>
@@ -5989,7 +5989,7 @@
         </p:nvSpPr>
         <p:spPr>
           <a:xfrm>
-            <a:off x="6442862" y="3017520"/>
+            <a:off x="6442862" y="3108960"/>
             <a:ext cx="603504" cy="603504"/>
           </a:xfrm>
           <a:prstGeom prst="ellipse">
@@ -6022,7 +6022,7 @@
         </p:blipFill>
         <p:spPr>
           <a:xfrm>
-            <a:off x="6587703" y="3162361"/>
+            <a:off x="6587703" y="3253801"/>
             <a:ext cx="313822" cy="313822"/>
           </a:xfrm>
           <a:prstGeom prst="rect">
@@ -6038,7 +6038,7 @@
         </p:nvSpPr>
         <p:spPr>
           <a:xfrm>
-            <a:off x="6442862" y="3767328"/>
+            <a:off x="6442862" y="3858768"/>
             <a:ext cx="2148840" cy="411480"/>
           </a:xfrm>
           <a:prstGeom prst="rect">
@@ -6077,7 +6077,7 @@
         </p:nvSpPr>
         <p:spPr>
           <a:xfrm>
-            <a:off x="6442862" y="4251960"/>
+            <a:off x="6442862" y="4343400"/>
             <a:ext cx="2148840" cy="1554480"/>
           </a:xfrm>
           <a:prstGeom prst="rect">
@@ -6116,8 +6116,8 @@
         </p:nvSpPr>
         <p:spPr>
           <a:xfrm>
-            <a:off x="9005926" y="2743200"/>
-            <a:ext cx="2606040" cy="3246120"/>
+            <a:off x="9005926" y="2834640"/>
+            <a:ext cx="2606040" cy="3154680"/>
           </a:xfrm>
           <a:prstGeom prst="roundRect">
             <a:avLst>
@@ -6143,7 +6143,7 @@
         </p:nvSpPr>
         <p:spPr>
           <a:xfrm>
-            <a:off x="9261958" y="3017520"/>
+            <a:off x="9261958" y="3108960"/>
             <a:ext cx="603504" cy="603504"/>
           </a:xfrm>
           <a:prstGeom prst="ellipse">
@@ -6176,7 +6176,7 @@
         </p:blipFill>
         <p:spPr>
           <a:xfrm>
-            <a:off x="9406799" y="3162361"/>
+            <a:off x="9406799" y="3253801"/>
             <a:ext cx="313822" cy="313822"/>
           </a:xfrm>
           <a:prstGeom prst="rect">
@@ -6192,7 +6192,7 @@
         </p:nvSpPr>
         <p:spPr>
           <a:xfrm>
-            <a:off x="9261958" y="3767328"/>
+            <a:off x="9261958" y="3858768"/>
             <a:ext cx="2148840" cy="411480"/>
           </a:xfrm>
           <a:prstGeom prst="rect">
@@ -6231,7 +6231,7 @@
         </p:nvSpPr>
         <p:spPr>
           <a:xfrm>
-            <a:off x="9261958" y="4251960"/>
+            <a:off x="9261958" y="4343400"/>
             <a:ext cx="2148840" cy="1554480"/>
           </a:xfrm>
           <a:prstGeom prst="rect">
@@ -6431,7 +6431,7 @@
         </p:blipFill>
         <p:spPr>
           <a:xfrm>
-            <a:off x="640080" y="2176272"/>
+            <a:off x="640080" y="2212848"/>
             <a:ext cx="329184" cy="329184"/>
           </a:xfrm>
           <a:prstGeom prst="rect">
@@ -6447,7 +6447,7 @@
         </p:nvSpPr>
         <p:spPr>
           <a:xfrm>
-            <a:off x="1143000" y="2103120"/>
+            <a:off x="1143000" y="2121408"/>
             <a:ext cx="4754880" cy="502920"/>
           </a:xfrm>
           <a:prstGeom prst="rect">
@@ -6472,7 +6472,7 @@
                 <a:ea typeface="Barlow" pitchFamily="34" charset="-122"/>
                 <a:cs typeface="Barlow" pitchFamily="34" charset="-120"/>
               </a:rPr>
-              <a:t>Le site pour l'administration, les enseignants et les étudiants</a:t>
+              <a:t>Le site web, pour toute l'école</a:t>
             </a:r>
             <a:endParaRPr lang="en-US" sz="1700" dirty="0"/>
           </a:p>
@@ -6494,7 +6494,7 @@
         </p:blipFill>
         <p:spPr>
           <a:xfrm>
-            <a:off x="640080" y="2889504"/>
+            <a:off x="640080" y="3017520"/>
             <a:ext cx="329184" cy="329184"/>
           </a:xfrm>
           <a:prstGeom prst="rect">
@@ -6510,7 +6510,7 @@
         </p:nvSpPr>
         <p:spPr>
           <a:xfrm>
-            <a:off x="1143000" y="2816352"/>
+            <a:off x="1143000" y="2926080"/>
             <a:ext cx="4754880" cy="502920"/>
           </a:xfrm>
           <a:prstGeom prst="rect">
@@ -6557,7 +6557,7 @@
         </p:blipFill>
         <p:spPr>
           <a:xfrm>
-            <a:off x="640080" y="3602736"/>
+            <a:off x="640080" y="3822192"/>
             <a:ext cx="329184" cy="329184"/>
           </a:xfrm>
           <a:prstGeom prst="rect">
@@ -6573,7 +6573,7 @@
         </p:nvSpPr>
         <p:spPr>
           <a:xfrm>
-            <a:off x="1143000" y="3529584"/>
+            <a:off x="1143000" y="3730752"/>
             <a:ext cx="4754880" cy="502920"/>
           </a:xfrm>
           <a:prstGeom prst="rect">
@@ -6620,7 +6620,7 @@
         </p:blipFill>
         <p:spPr>
           <a:xfrm>
-            <a:off x="640080" y="4315968"/>
+            <a:off x="640080" y="4626864"/>
             <a:ext cx="329184" cy="329184"/>
           </a:xfrm>
           <a:prstGeom prst="rect">
@@ -6636,7 +6636,7 @@
         </p:nvSpPr>
         <p:spPr>
           <a:xfrm>
-            <a:off x="1143000" y="4242816"/>
+            <a:off x="1143000" y="4535424"/>
             <a:ext cx="4754880" cy="502920"/>
           </a:xfrm>
           <a:prstGeom prst="rect">

</xml_diff>